<commit_message>
docs: ajustes de layout e texto nos slides, EKS 1.33
</commit_message>
<xml_diff>
--- a/docs/apresentacao/Tech-Challenge-Fase2.pptx
+++ b/docs/apresentacao/Tech-Challenge-Fase2.pptx
@@ -5340,7 +5340,7 @@
         <p:spPr>
           <a:xfrm>
             <a:off x="822960" y="1783080"/>
-            <a:ext cx="8647536" cy="640080"/>
+            <a:ext cx="9555480" cy="640080"/>
           </a:xfrm>
           <a:prstGeom prst="rect">
             <a:avLst/>
@@ -5838,7 +5838,7 @@
                 <a:ea typeface="Segoe UI" pitchFamily="34" charset="-122"/>
                 <a:cs typeface="Segoe UI" pitchFamily="34" charset="-120"/>
               </a:rPr>
-              <a:t>O dia a dia é separado.</a:t>
+              <a:t>Serviços separados.</a:t>
             </a:r>
             <a:pPr indent="0" marL="0">
               <a:lnSpc>
@@ -7445,7 +7445,7 @@
                 <a:ea typeface="Segoe UI" pitchFamily="34" charset="-122"/>
                 <a:cs typeface="Segoe UI" pitchFamily="34" charset="-120"/>
               </a:rPr>
-              <a:t>  EKS 1.31, node group gerenciado de 2 a 3 nós t3.small.</a:t>
+              <a:t>  EKS 1.33, node group gerenciado de 2 a 3 nós t3.small.</a:t>
             </a:r>
             <a:endParaRPr lang="en-US" sz="1200" dirty="0"/>
           </a:p>

</xml_diff>